<commit_message>
Add powerpoint presentation features
</commit_message>
<xml_diff>
--- a/generated/presentation.pptx
+++ b/generated/presentation.pptx
@@ -11,6 +11,11 @@
     <p:sldId id="259" r:id="rId10"/>
     <p:sldId id="260" r:id="rId11"/>
     <p:sldId id="261" r:id="rId12"/>
+    <p:sldId id="262" r:id="rId13"/>
+    <p:sldId id="263" r:id="rId14"/>
+    <p:sldId id="264" r:id="rId15"/>
+    <p:sldId id="265" r:id="rId16"/>
+    <p:sldId id="266" r:id="rId17"/>
   </p:sldIdLst>
   <p:sldSz cx="9144000" cy="6858000" type="screen4x3"/>
   <p:notesSz cx="6858000" cy="9144000"/>
@@ -3093,44 +3098,532 @@
         <p:nvPr/>
       </p:nvGrpSpPr>
       <p:grpSpPr/>
-      <p:sp>
-        <p:nvSpPr>
-          <p:cNvPr id="2" name="Title 1"/>
-          <p:cNvSpPr>
-            <a:spLocks noGrp="1"/>
-          </p:cNvSpPr>
-          <p:nvPr>
-            <p:ph type="ctrTitle"/>
-          </p:nvPr>
-        </p:nvSpPr>
-        <p:spPr/>
-        <p:txBody>
-          <a:bodyPr/>
-          <a:lstStyle/>
-          <a:p>
-            <a:r>
-              <a:t>Sex Education</a:t>
-            </a:r>
-          </a:p>
-        </p:txBody>
-      </p:sp>
-      <p:sp>
-        <p:nvSpPr>
-          <p:cNvPr id="3" name="Subtitle 2"/>
-          <p:cNvSpPr>
-            <a:spLocks noGrp="1"/>
-          </p:cNvSpPr>
-          <p:nvPr>
-            <p:ph type="subTitle" idx="1"/>
-          </p:nvPr>
-        </p:nvSpPr>
-        <p:spPr/>
-        <p:txBody>
-          <a:bodyPr/>
-          <a:lstStyle/>
-          <a:p>
+      <p:pic>
+        <p:nvPicPr>
+          <p:cNvPr id="2" name="Picture 1" descr="background.jpg"/>
+          <p:cNvPicPr>
+            <a:picLocks noChangeAspect="1"/>
+          </p:cNvPicPr>
+          <p:nvPr/>
+        </p:nvPicPr>
+        <p:blipFill>
+          <a:blip r:embed="rId2"/>
+          <a:stretch>
+            <a:fillRect/>
+          </a:stretch>
+        </p:blipFill>
+        <p:spPr>
+          <a:xfrm>
+            <a:off x="0" y="0"/>
+            <a:ext cx="9144000" cy="6858000"/>
+          </a:xfrm>
+          <a:prstGeom prst="rect">
+            <a:avLst/>
+          </a:prstGeom>
+        </p:spPr>
+      </p:pic>
+      <p:pic>
+        <p:nvPicPr>
+          <p:cNvPr id="3" name="Picture 2" descr="logo.png"/>
+          <p:cNvPicPr>
+            <a:picLocks noChangeAspect="1"/>
+          </p:cNvPicPr>
+          <p:nvPr/>
+        </p:nvPicPr>
+        <p:blipFill>
+          <a:blip r:embed="rId3"/>
+          <a:stretch>
+            <a:fillRect/>
+          </a:stretch>
+        </p:blipFill>
+        <p:spPr>
+          <a:xfrm>
+            <a:off x="7315200" y="320040"/>
+            <a:ext cx="731520" cy="731520"/>
+          </a:xfrm>
+          <a:prstGeom prst="rect">
+            <a:avLst/>
+          </a:prstGeom>
+        </p:spPr>
+      </p:pic>
+      <p:sp>
+        <p:nvSpPr>
+          <p:cNvPr id="4" name="TextBox 3"/>
+          <p:cNvSpPr txBox="1"/>
+          <p:nvPr/>
+        </p:nvSpPr>
+        <p:spPr>
+          <a:xfrm>
+            <a:off x="1645920" y="1097280"/>
+            <a:ext cx="7498079" cy="914400"/>
+          </a:xfrm>
+          <a:prstGeom prst="rect">
+            <a:avLst/>
+          </a:prstGeom>
+          <a:noFill/>
+        </p:spPr>
+        <p:txBody>
+          <a:bodyPr wrap="none">
+            <a:spAutoFit/>
+          </a:bodyPr>
+          <a:lstStyle/>
+          <a:p>
+            <a:pPr algn="l">
+              <a:defRPr sz="3200" b="1">
+                <a:solidFill>
+                  <a:srgbClr val="222222"/>
+                </a:solidFill>
+                <a:latin typeface="Aptos"/>
+              </a:defRPr>
+            </a:pPr>
+            <a:r>
+              <a:t>The Journey of Life</a:t>
+            </a:r>
+          </a:p>
+        </p:txBody>
+      </p:sp>
+      <p:sp>
+        <p:nvSpPr>
+          <p:cNvPr id="5" name="TextBox 4"/>
+          <p:cNvSpPr txBox="1"/>
+          <p:nvPr/>
+        </p:nvSpPr>
+        <p:spPr>
+          <a:xfrm>
+            <a:off x="1645920" y="1691640"/>
+            <a:ext cx="7315200" cy="365760"/>
+          </a:xfrm>
+          <a:prstGeom prst="rect">
+            <a:avLst/>
+          </a:prstGeom>
+          <a:noFill/>
+        </p:spPr>
+        <p:txBody>
+          <a:bodyPr wrap="none">
+            <a:spAutoFit/>
+          </a:bodyPr>
+          <a:lstStyle/>
+          <a:p>
+            <a:pPr>
+              <a:defRPr sz="1600">
+                <a:solidFill>
+                  <a:srgbClr val="323232"/>
+                </a:solidFill>
+                <a:latin typeface="Aptos"/>
+              </a:defRPr>
+            </a:pPr>
             <a:r>
               <a:t>Generated by Mak-AI</a:t>
+            </a:r>
+          </a:p>
+        </p:txBody>
+      </p:sp>
+    </p:spTree>
+  </p:cSld>
+  <p:clrMapOvr>
+    <a:masterClrMapping/>
+  </p:clrMapOvr>
+</p:sld>
+</file>
+
+<file path=ppt/slides/slide10.xml><?xml version="1.0" encoding="utf-8"?>
+<p:sld xmlns:a="http://schemas.openxmlformats.org/drawingml/2006/main" xmlns:p="http://schemas.openxmlformats.org/presentationml/2006/main" xmlns:r="http://schemas.openxmlformats.org/officeDocument/2006/relationships">
+  <p:cSld>
+    <p:spTree>
+      <p:nvGrpSpPr>
+        <p:cNvPr id="1" name=""/>
+        <p:cNvGrpSpPr/>
+        <p:nvPr/>
+      </p:nvGrpSpPr>
+      <p:grpSpPr/>
+      <p:pic>
+        <p:nvPicPr>
+          <p:cNvPr id="2" name="Picture 1" descr="background.jpg"/>
+          <p:cNvPicPr>
+            <a:picLocks noChangeAspect="1"/>
+          </p:cNvPicPr>
+          <p:nvPr/>
+        </p:nvPicPr>
+        <p:blipFill>
+          <a:blip r:embed="rId2"/>
+          <a:stretch>
+            <a:fillRect/>
+          </a:stretch>
+        </p:blipFill>
+        <p:spPr>
+          <a:xfrm>
+            <a:off x="0" y="0"/>
+            <a:ext cx="9144000" cy="6858000"/>
+          </a:xfrm>
+          <a:prstGeom prst="rect">
+            <a:avLst/>
+          </a:prstGeom>
+        </p:spPr>
+      </p:pic>
+      <p:pic>
+        <p:nvPicPr>
+          <p:cNvPr id="3" name="Picture 2" descr="logo.png"/>
+          <p:cNvPicPr>
+            <a:picLocks noChangeAspect="1"/>
+          </p:cNvPicPr>
+          <p:nvPr/>
+        </p:nvPicPr>
+        <p:blipFill>
+          <a:blip r:embed="rId3"/>
+          <a:stretch>
+            <a:fillRect/>
+          </a:stretch>
+        </p:blipFill>
+        <p:spPr>
+          <a:xfrm>
+            <a:off x="7315200" y="320040"/>
+            <a:ext cx="731520" cy="731520"/>
+          </a:xfrm>
+          <a:prstGeom prst="rect">
+            <a:avLst/>
+          </a:prstGeom>
+        </p:spPr>
+      </p:pic>
+      <p:sp>
+        <p:nvSpPr>
+          <p:cNvPr id="4" name="TextBox 3"/>
+          <p:cNvSpPr txBox="1"/>
+          <p:nvPr/>
+        </p:nvSpPr>
+        <p:spPr>
+          <a:xfrm>
+            <a:off x="1645920" y="1097280"/>
+            <a:ext cx="7498079" cy="914400"/>
+          </a:xfrm>
+          <a:prstGeom prst="rect">
+            <a:avLst/>
+          </a:prstGeom>
+          <a:noFill/>
+        </p:spPr>
+        <p:txBody>
+          <a:bodyPr wrap="none">
+            <a:spAutoFit/>
+          </a:bodyPr>
+          <a:lstStyle/>
+          <a:p>
+            <a:pPr algn="l">
+              <a:defRPr sz="3200" b="1">
+                <a:solidFill>
+                  <a:srgbClr val="222222"/>
+                </a:solidFill>
+                <a:latin typeface="Aptos"/>
+              </a:defRPr>
+            </a:pPr>
+            <a:r>
+              <a:t>Summary</a:t>
+            </a:r>
+          </a:p>
+        </p:txBody>
+      </p:sp>
+      <p:sp>
+        <p:nvSpPr>
+          <p:cNvPr id="5" name="TextBox 4"/>
+          <p:cNvSpPr txBox="1"/>
+          <p:nvPr/>
+        </p:nvSpPr>
+        <p:spPr>
+          <a:xfrm>
+            <a:off x="731520" y="1600200"/>
+            <a:ext cx="4754880" cy="4206240"/>
+          </a:xfrm>
+          <a:prstGeom prst="rect">
+            <a:avLst/>
+          </a:prstGeom>
+          <a:noFill/>
+        </p:spPr>
+        <p:txBody>
+          <a:bodyPr wrap="square">
+            <a:spAutoFit/>
+          </a:bodyPr>
+          <a:lstStyle/>
+          <a:p>
+            <a:pPr>
+              <a:spcAft>
+                <a:spcPts val="800"/>
+              </a:spcAft>
+              <a:defRPr sz="1800">
+                <a:solidFill>
+                  <a:srgbClr val="323232"/>
+                </a:solidFill>
+                <a:latin typeface="Aptos"/>
+              </a:defRPr>
+            </a:pPr>
+            <a:r>
+              <a:t>• Life is a complex, dynamic, and multifaceted journey</a:t>
+            </a:r>
+          </a:p>
+          <a:p>
+            <a:pPr>
+              <a:spcAft>
+                <a:spcPts val="800"/>
+              </a:spcAft>
+              <a:defRPr sz="1800">
+                <a:solidFill>
+                  <a:srgbClr val="323232"/>
+                </a:solidFill>
+                <a:latin typeface="Aptos"/>
+              </a:defRPr>
+            </a:pPr>
+            <a:r>
+              <a:t>• Characterized by growth, challenges, and opportunities</a:t>
+            </a:r>
+          </a:p>
+          <a:p>
+            <a:pPr>
+              <a:spcAft>
+                <a:spcPts val="800"/>
+              </a:spcAft>
+              <a:defRPr sz="1800">
+                <a:solidFill>
+                  <a:srgbClr val="323232"/>
+                </a:solidFill>
+                <a:latin typeface="Aptos"/>
+              </a:defRPr>
+            </a:pPr>
+            <a:r>
+              <a:t>• Requires self-awareness, resilience, and adaptability</a:t>
+            </a:r>
+          </a:p>
+          <a:p>
+            <a:pPr>
+              <a:spcAft>
+                <a:spcPts val="800"/>
+              </a:spcAft>
+              <a:defRPr sz="1800">
+                <a:solidFill>
+                  <a:srgbClr val="323232"/>
+                </a:solidFill>
+                <a:latin typeface="Aptos"/>
+              </a:defRPr>
+            </a:pPr>
+            <a:r>
+              <a:t>• Involves building strong relationships and connections</a:t>
+            </a:r>
+          </a:p>
+          <a:p>
+            <a:pPr>
+              <a:spcAft>
+                <a:spcPts val="800"/>
+              </a:spcAft>
+              <a:defRPr sz="1800">
+                <a:solidFill>
+                  <a:srgbClr val="323232"/>
+                </a:solidFill>
+                <a:latin typeface="Aptos"/>
+              </a:defRPr>
+            </a:pPr>
+            <a:r>
+              <a:t>• Ultimately, leads to personal fulfillment and happiness</a:t>
+            </a:r>
+          </a:p>
+        </p:txBody>
+      </p:sp>
+    </p:spTree>
+  </p:cSld>
+  <p:clrMapOvr>
+    <a:masterClrMapping/>
+  </p:clrMapOvr>
+</p:sld>
+</file>
+
+<file path=ppt/slides/slide11.xml><?xml version="1.0" encoding="utf-8"?>
+<p:sld xmlns:a="http://schemas.openxmlformats.org/drawingml/2006/main" xmlns:p="http://schemas.openxmlformats.org/presentationml/2006/main" xmlns:r="http://schemas.openxmlformats.org/officeDocument/2006/relationships">
+  <p:cSld>
+    <p:spTree>
+      <p:nvGrpSpPr>
+        <p:cNvPr id="1" name=""/>
+        <p:cNvGrpSpPr/>
+        <p:nvPr/>
+      </p:nvGrpSpPr>
+      <p:grpSpPr/>
+      <p:pic>
+        <p:nvPicPr>
+          <p:cNvPr id="2" name="Picture 1" descr="background.jpg"/>
+          <p:cNvPicPr>
+            <a:picLocks noChangeAspect="1"/>
+          </p:cNvPicPr>
+          <p:nvPr/>
+        </p:nvPicPr>
+        <p:blipFill>
+          <a:blip r:embed="rId2"/>
+          <a:stretch>
+            <a:fillRect/>
+          </a:stretch>
+        </p:blipFill>
+        <p:spPr>
+          <a:xfrm>
+            <a:off x="0" y="0"/>
+            <a:ext cx="9144000" cy="6858000"/>
+          </a:xfrm>
+          <a:prstGeom prst="rect">
+            <a:avLst/>
+          </a:prstGeom>
+        </p:spPr>
+      </p:pic>
+      <p:pic>
+        <p:nvPicPr>
+          <p:cNvPr id="3" name="Picture 2" descr="logo.png"/>
+          <p:cNvPicPr>
+            <a:picLocks noChangeAspect="1"/>
+          </p:cNvPicPr>
+          <p:nvPr/>
+        </p:nvPicPr>
+        <p:blipFill>
+          <a:blip r:embed="rId3"/>
+          <a:stretch>
+            <a:fillRect/>
+          </a:stretch>
+        </p:blipFill>
+        <p:spPr>
+          <a:xfrm>
+            <a:off x="7315200" y="320040"/>
+            <a:ext cx="731520" cy="731520"/>
+          </a:xfrm>
+          <a:prstGeom prst="rect">
+            <a:avLst/>
+          </a:prstGeom>
+        </p:spPr>
+      </p:pic>
+      <p:sp>
+        <p:nvSpPr>
+          <p:cNvPr id="4" name="TextBox 3"/>
+          <p:cNvSpPr txBox="1"/>
+          <p:nvPr/>
+        </p:nvSpPr>
+        <p:spPr>
+          <a:xfrm>
+            <a:off x="1645920" y="1097280"/>
+            <a:ext cx="7498079" cy="914400"/>
+          </a:xfrm>
+          <a:prstGeom prst="rect">
+            <a:avLst/>
+          </a:prstGeom>
+          <a:noFill/>
+        </p:spPr>
+        <p:txBody>
+          <a:bodyPr wrap="none">
+            <a:spAutoFit/>
+          </a:bodyPr>
+          <a:lstStyle/>
+          <a:p>
+            <a:pPr algn="l">
+              <a:defRPr sz="3200" b="1">
+                <a:solidFill>
+                  <a:srgbClr val="222222"/>
+                </a:solidFill>
+                <a:latin typeface="Aptos"/>
+              </a:defRPr>
+            </a:pPr>
+            <a:r>
+              <a:t>Conclusion</a:t>
+            </a:r>
+          </a:p>
+        </p:txBody>
+      </p:sp>
+      <p:sp>
+        <p:nvSpPr>
+          <p:cNvPr id="5" name="TextBox 4"/>
+          <p:cNvSpPr txBox="1"/>
+          <p:nvPr/>
+        </p:nvSpPr>
+        <p:spPr>
+          <a:xfrm>
+            <a:off x="731520" y="1600200"/>
+            <a:ext cx="4754880" cy="4206240"/>
+          </a:xfrm>
+          <a:prstGeom prst="rect">
+            <a:avLst/>
+          </a:prstGeom>
+          <a:noFill/>
+        </p:spPr>
+        <p:txBody>
+          <a:bodyPr wrap="square">
+            <a:spAutoFit/>
+          </a:bodyPr>
+          <a:lstStyle/>
+          <a:p>
+            <a:pPr>
+              <a:spcAft>
+                <a:spcPts val="800"/>
+              </a:spcAft>
+              <a:defRPr sz="1800">
+                <a:solidFill>
+                  <a:srgbClr val="323232"/>
+                </a:solidFill>
+                <a:latin typeface="Aptos"/>
+              </a:defRPr>
+            </a:pPr>
+            <a:r>
+              <a:t>• Embracing life's journey with curiosity and openness</a:t>
+            </a:r>
+          </a:p>
+          <a:p>
+            <a:pPr>
+              <a:spcAft>
+                <a:spcPts val="800"/>
+              </a:spcAft>
+              <a:defRPr sz="1800">
+                <a:solidFill>
+                  <a:srgbClr val="323232"/>
+                </a:solidFill>
+                <a:latin typeface="Aptos"/>
+              </a:defRPr>
+            </a:pPr>
+            <a:r>
+              <a:t>• Cultivating a growth mindset and positive attitude</a:t>
+            </a:r>
+          </a:p>
+          <a:p>
+            <a:pPr>
+              <a:spcAft>
+                <a:spcPts val="800"/>
+              </a:spcAft>
+              <a:defRPr sz="1800">
+                <a:solidFill>
+                  <a:srgbClr val="323232"/>
+                </a:solidFill>
+                <a:latin typeface="Aptos"/>
+              </a:defRPr>
+            </a:pPr>
+            <a:r>
+              <a:t>• Focusing on personal growth and self-improvement</a:t>
+            </a:r>
+          </a:p>
+          <a:p>
+            <a:pPr>
+              <a:spcAft>
+                <a:spcPts val="800"/>
+              </a:spcAft>
+              <a:defRPr sz="1800">
+                <a:solidFill>
+                  <a:srgbClr val="323232"/>
+                </a:solidFill>
+                <a:latin typeface="Aptos"/>
+              </a:defRPr>
+            </a:pPr>
+            <a:r>
+              <a:t>• Nurturing meaningful relationships and connections</a:t>
+            </a:r>
+          </a:p>
+          <a:p>
+            <a:pPr>
+              <a:spcAft>
+                <a:spcPts val="800"/>
+              </a:spcAft>
+              <a:defRPr sz="1800">
+                <a:solidFill>
+                  <a:srgbClr val="323232"/>
+                </a:solidFill>
+                <a:latin typeface="Aptos"/>
+              </a:defRPr>
+            </a:pPr>
+            <a:r>
+              <a:t>• Striving for happiness, fulfillment, and purpose</a:t>
             </a:r>
           </a:p>
         </p:txBody>
@@ -3153,63 +3646,189 @@
         <p:nvPr/>
       </p:nvGrpSpPr>
       <p:grpSpPr/>
-      <p:sp>
-        <p:nvSpPr>
-          <p:cNvPr id="2" name="Title 1"/>
-          <p:cNvSpPr>
-            <a:spLocks noGrp="1"/>
-          </p:cNvSpPr>
-          <p:nvPr>
-            <p:ph type="title"/>
-          </p:nvPr>
-        </p:nvSpPr>
-        <p:spPr/>
-        <p:txBody>
-          <a:bodyPr/>
-          <a:lstStyle/>
-          <a:p>
-            <a:r>
-              <a:t>Introduction to Sex</a:t>
-            </a:r>
-          </a:p>
-        </p:txBody>
-      </p:sp>
-      <p:sp>
-        <p:nvSpPr>
-          <p:cNvPr id="3" name="Content Placeholder 2"/>
-          <p:cNvSpPr>
-            <a:spLocks noGrp="1"/>
-          </p:cNvSpPr>
-          <p:nvPr>
-            <p:ph idx="1"/>
-          </p:nvPr>
-        </p:nvSpPr>
-        <p:spPr/>
-        <p:txBody>
-          <a:bodyPr/>
-          <a:lstStyle/>
-          <a:p>
-            <a:pPr/>
-            <a:r>
-              <a:t>Definition of Sex</a:t>
-            </a:r>
-          </a:p>
-          <a:p>
-            <a:pPr/>
-            <a:r>
-              <a:t>Importance of Sex Education</a:t>
-            </a:r>
-          </a:p>
-          <a:p>
-            <a:pPr/>
-            <a:r>
-              <a:t>Myths and Misconceptions</a:t>
-            </a:r>
-          </a:p>
-          <a:p>
-            <a:pPr/>
-            <a:r>
-              <a:t>Setting Boundaries</a:t>
+      <p:pic>
+        <p:nvPicPr>
+          <p:cNvPr id="2" name="Picture 1" descr="background.jpg"/>
+          <p:cNvPicPr>
+            <a:picLocks noChangeAspect="1"/>
+          </p:cNvPicPr>
+          <p:nvPr/>
+        </p:nvPicPr>
+        <p:blipFill>
+          <a:blip r:embed="rId2"/>
+          <a:stretch>
+            <a:fillRect/>
+          </a:stretch>
+        </p:blipFill>
+        <p:spPr>
+          <a:xfrm>
+            <a:off x="0" y="0"/>
+            <a:ext cx="9144000" cy="6858000"/>
+          </a:xfrm>
+          <a:prstGeom prst="rect">
+            <a:avLst/>
+          </a:prstGeom>
+        </p:spPr>
+      </p:pic>
+      <p:pic>
+        <p:nvPicPr>
+          <p:cNvPr id="3" name="Picture 2" descr="logo.png"/>
+          <p:cNvPicPr>
+            <a:picLocks noChangeAspect="1"/>
+          </p:cNvPicPr>
+          <p:nvPr/>
+        </p:nvPicPr>
+        <p:blipFill>
+          <a:blip r:embed="rId3"/>
+          <a:stretch>
+            <a:fillRect/>
+          </a:stretch>
+        </p:blipFill>
+        <p:spPr>
+          <a:xfrm>
+            <a:off x="7315200" y="320040"/>
+            <a:ext cx="731520" cy="731520"/>
+          </a:xfrm>
+          <a:prstGeom prst="rect">
+            <a:avLst/>
+          </a:prstGeom>
+        </p:spPr>
+      </p:pic>
+      <p:sp>
+        <p:nvSpPr>
+          <p:cNvPr id="4" name="TextBox 3"/>
+          <p:cNvSpPr txBox="1"/>
+          <p:nvPr/>
+        </p:nvSpPr>
+        <p:spPr>
+          <a:xfrm>
+            <a:off x="1645920" y="1097280"/>
+            <a:ext cx="7498079" cy="914400"/>
+          </a:xfrm>
+          <a:prstGeom prst="rect">
+            <a:avLst/>
+          </a:prstGeom>
+          <a:noFill/>
+        </p:spPr>
+        <p:txBody>
+          <a:bodyPr wrap="none">
+            <a:spAutoFit/>
+          </a:bodyPr>
+          <a:lstStyle/>
+          <a:p>
+            <a:pPr algn="l">
+              <a:defRPr sz="3200" b="1">
+                <a:solidFill>
+                  <a:srgbClr val="222222"/>
+                </a:solidFill>
+                <a:latin typeface="Aptos"/>
+              </a:defRPr>
+            </a:pPr>
+            <a:r>
+              <a:t>Introduction</a:t>
+            </a:r>
+          </a:p>
+        </p:txBody>
+      </p:sp>
+      <p:sp>
+        <p:nvSpPr>
+          <p:cNvPr id="5" name="TextBox 4"/>
+          <p:cNvSpPr txBox="1"/>
+          <p:nvPr/>
+        </p:nvSpPr>
+        <p:spPr>
+          <a:xfrm>
+            <a:off x="731520" y="1600200"/>
+            <a:ext cx="4754880" cy="4206240"/>
+          </a:xfrm>
+          <a:prstGeom prst="rect">
+            <a:avLst/>
+          </a:prstGeom>
+          <a:noFill/>
+        </p:spPr>
+        <p:txBody>
+          <a:bodyPr wrap="square">
+            <a:spAutoFit/>
+          </a:bodyPr>
+          <a:lstStyle/>
+          <a:p>
+            <a:pPr>
+              <a:spcAft>
+                <a:spcPts val="800"/>
+              </a:spcAft>
+              <a:defRPr sz="1800">
+                <a:solidFill>
+                  <a:srgbClr val="323232"/>
+                </a:solidFill>
+                <a:latin typeface="Aptos"/>
+              </a:defRPr>
+            </a:pPr>
+            <a:r>
+              <a:t>• Life is a precious gift to humans</a:t>
+            </a:r>
+          </a:p>
+          <a:p>
+            <a:pPr>
+              <a:spcAft>
+                <a:spcPts val="800"/>
+              </a:spcAft>
+              <a:defRPr sz="1800">
+                <a:solidFill>
+                  <a:srgbClr val="323232"/>
+                </a:solidFill>
+                <a:latin typeface="Aptos"/>
+              </a:defRPr>
+            </a:pPr>
+            <a:r>
+              <a:t>• Filled with experiences and learning</a:t>
+            </a:r>
+          </a:p>
+          <a:p>
+            <a:pPr>
+              <a:spcAft>
+                <a:spcPts val="800"/>
+              </a:spcAft>
+              <a:defRPr sz="1800">
+                <a:solidFill>
+                  <a:srgbClr val="323232"/>
+                </a:solidFill>
+                <a:latin typeface="Aptos"/>
+              </a:defRPr>
+            </a:pPr>
+            <a:r>
+              <a:t>• Shaped by choices and circumstances</a:t>
+            </a:r>
+          </a:p>
+          <a:p>
+            <a:pPr>
+              <a:spcAft>
+                <a:spcPts val="800"/>
+              </a:spcAft>
+              <a:defRPr sz="1800">
+                <a:solidFill>
+                  <a:srgbClr val="323232"/>
+                </a:solidFill>
+                <a:latin typeface="Aptos"/>
+              </a:defRPr>
+            </a:pPr>
+            <a:r>
+              <a:t>• Involves growth, development, and evolution</a:t>
+            </a:r>
+          </a:p>
+          <a:p>
+            <a:pPr>
+              <a:spcAft>
+                <a:spcPts val="800"/>
+              </a:spcAft>
+              <a:defRPr sz="1800">
+                <a:solidFill>
+                  <a:srgbClr val="323232"/>
+                </a:solidFill>
+                <a:latin typeface="Aptos"/>
+              </a:defRPr>
+            </a:pPr>
+            <a:r>
+              <a:t>• Requires resilience and adaptability</a:t>
             </a:r>
           </a:p>
         </p:txBody>
@@ -3232,63 +3851,189 @@
         <p:nvPr/>
       </p:nvGrpSpPr>
       <p:grpSpPr/>
-      <p:sp>
-        <p:nvSpPr>
-          <p:cNvPr id="2" name="Title 1"/>
-          <p:cNvSpPr>
-            <a:spLocks noGrp="1"/>
-          </p:cNvSpPr>
-          <p:nvPr>
-            <p:ph type="title"/>
-          </p:nvPr>
-        </p:nvSpPr>
-        <p:spPr/>
-        <p:txBody>
-          <a:bodyPr/>
-          <a:lstStyle/>
-          <a:p>
-            <a:r>
-              <a:t>Human Reproductive System</a:t>
-            </a:r>
-          </a:p>
-        </p:txBody>
-      </p:sp>
-      <p:sp>
-        <p:nvSpPr>
-          <p:cNvPr id="3" name="Content Placeholder 2"/>
-          <p:cNvSpPr>
-            <a:spLocks noGrp="1"/>
-          </p:cNvSpPr>
-          <p:nvPr>
-            <p:ph idx="1"/>
-          </p:nvPr>
-        </p:nvSpPr>
-        <p:spPr/>
-        <p:txBody>
-          <a:bodyPr/>
-          <a:lstStyle/>
-          <a:p>
-            <a:pPr/>
-            <a:r>
-              <a:t>Male Reproductive Organs</a:t>
-            </a:r>
-          </a:p>
-          <a:p>
-            <a:pPr/>
-            <a:r>
-              <a:t>Female Reproductive Organs</a:t>
-            </a:r>
-          </a:p>
-          <a:p>
-            <a:pPr/>
-            <a:r>
-              <a:t>Hormones and Their Roles</a:t>
-            </a:r>
-          </a:p>
-          <a:p>
-            <a:pPr/>
-            <a:r>
-              <a:t>Fertility and Conception</a:t>
+      <p:pic>
+        <p:nvPicPr>
+          <p:cNvPr id="2" name="Picture 1" descr="background.jpg"/>
+          <p:cNvPicPr>
+            <a:picLocks noChangeAspect="1"/>
+          </p:cNvPicPr>
+          <p:nvPr/>
+        </p:nvPicPr>
+        <p:blipFill>
+          <a:blip r:embed="rId2"/>
+          <a:stretch>
+            <a:fillRect/>
+          </a:stretch>
+        </p:blipFill>
+        <p:spPr>
+          <a:xfrm>
+            <a:off x="0" y="0"/>
+            <a:ext cx="9144000" cy="6858000"/>
+          </a:xfrm>
+          <a:prstGeom prst="rect">
+            <a:avLst/>
+          </a:prstGeom>
+        </p:spPr>
+      </p:pic>
+      <p:pic>
+        <p:nvPicPr>
+          <p:cNvPr id="3" name="Picture 2" descr="logo.png"/>
+          <p:cNvPicPr>
+            <a:picLocks noChangeAspect="1"/>
+          </p:cNvPicPr>
+          <p:nvPr/>
+        </p:nvPicPr>
+        <p:blipFill>
+          <a:blip r:embed="rId3"/>
+          <a:stretch>
+            <a:fillRect/>
+          </a:stretch>
+        </p:blipFill>
+        <p:spPr>
+          <a:xfrm>
+            <a:off x="7315200" y="320040"/>
+            <a:ext cx="731520" cy="731520"/>
+          </a:xfrm>
+          <a:prstGeom prst="rect">
+            <a:avLst/>
+          </a:prstGeom>
+        </p:spPr>
+      </p:pic>
+      <p:sp>
+        <p:nvSpPr>
+          <p:cNvPr id="4" name="TextBox 3"/>
+          <p:cNvSpPr txBox="1"/>
+          <p:nvPr/>
+        </p:nvSpPr>
+        <p:spPr>
+          <a:xfrm>
+            <a:off x="1645920" y="1097280"/>
+            <a:ext cx="7498079" cy="914400"/>
+          </a:xfrm>
+          <a:prstGeom prst="rect">
+            <a:avLst/>
+          </a:prstGeom>
+          <a:noFill/>
+        </p:spPr>
+        <p:txBody>
+          <a:bodyPr wrap="none">
+            <a:spAutoFit/>
+          </a:bodyPr>
+          <a:lstStyle/>
+          <a:p>
+            <a:pPr algn="l">
+              <a:defRPr sz="3200" b="1">
+                <a:solidFill>
+                  <a:srgbClr val="222222"/>
+                </a:solidFill>
+                <a:latin typeface="Aptos"/>
+              </a:defRPr>
+            </a:pPr>
+            <a:r>
+              <a:t>Background</a:t>
+            </a:r>
+          </a:p>
+        </p:txBody>
+      </p:sp>
+      <p:sp>
+        <p:nvSpPr>
+          <p:cNvPr id="5" name="TextBox 4"/>
+          <p:cNvSpPr txBox="1"/>
+          <p:nvPr/>
+        </p:nvSpPr>
+        <p:spPr>
+          <a:xfrm>
+            <a:off x="731520" y="1600200"/>
+            <a:ext cx="4754880" cy="4206240"/>
+          </a:xfrm>
+          <a:prstGeom prst="rect">
+            <a:avLst/>
+          </a:prstGeom>
+          <a:noFill/>
+        </p:spPr>
+        <p:txBody>
+          <a:bodyPr wrap="square">
+            <a:spAutoFit/>
+          </a:bodyPr>
+          <a:lstStyle/>
+          <a:p>
+            <a:pPr>
+              <a:spcAft>
+                <a:spcPts val="800"/>
+              </a:spcAft>
+              <a:defRPr sz="1800">
+                <a:solidFill>
+                  <a:srgbClr val="323232"/>
+                </a:solidFill>
+                <a:latin typeface="Aptos"/>
+              </a:defRPr>
+            </a:pPr>
+            <a:r>
+              <a:t>• Originates from birth and upbringing</a:t>
+            </a:r>
+          </a:p>
+          <a:p>
+            <a:pPr>
+              <a:spcAft>
+                <a:spcPts val="800"/>
+              </a:spcAft>
+              <a:defRPr sz="1800">
+                <a:solidFill>
+                  <a:srgbClr val="323232"/>
+                </a:solidFill>
+                <a:latin typeface="Aptos"/>
+              </a:defRPr>
+            </a:pPr>
+            <a:r>
+              <a:t>• Influenced by family, culture, and society</a:t>
+            </a:r>
+          </a:p>
+          <a:p>
+            <a:pPr>
+              <a:spcAft>
+                <a:spcPts val="800"/>
+              </a:spcAft>
+              <a:defRPr sz="1800">
+                <a:solidFill>
+                  <a:srgbClr val="323232"/>
+                </a:solidFill>
+                <a:latin typeface="Aptos"/>
+              </a:defRPr>
+            </a:pPr>
+            <a:r>
+              <a:t>• Comprises physical, emotional, and mental aspects</a:t>
+            </a:r>
+          </a:p>
+          <a:p>
+            <a:pPr>
+              <a:spcAft>
+                <a:spcPts val="800"/>
+              </a:spcAft>
+              <a:defRPr sz="1800">
+                <a:solidFill>
+                  <a:srgbClr val="323232"/>
+                </a:solidFill>
+                <a:latin typeface="Aptos"/>
+              </a:defRPr>
+            </a:pPr>
+            <a:r>
+              <a:t>• Impacted by relationships and interactions</a:t>
+            </a:r>
+          </a:p>
+          <a:p>
+            <a:pPr>
+              <a:spcAft>
+                <a:spcPts val="800"/>
+              </a:spcAft>
+              <a:defRPr sz="1800">
+                <a:solidFill>
+                  <a:srgbClr val="323232"/>
+                </a:solidFill>
+                <a:latin typeface="Aptos"/>
+              </a:defRPr>
+            </a:pPr>
+            <a:r>
+              <a:t>• Evokes emotions, thoughts, and feelings</a:t>
             </a:r>
           </a:p>
         </p:txBody>
@@ -3311,63 +4056,189 @@
         <p:nvPr/>
       </p:nvGrpSpPr>
       <p:grpSpPr/>
-      <p:sp>
-        <p:nvSpPr>
-          <p:cNvPr id="2" name="Title 1"/>
-          <p:cNvSpPr>
-            <a:spLocks noGrp="1"/>
-          </p:cNvSpPr>
-          <p:nvPr>
-            <p:ph type="title"/>
-          </p:nvPr>
-        </p:nvSpPr>
-        <p:spPr/>
-        <p:txBody>
-          <a:bodyPr/>
-          <a:lstStyle/>
-          <a:p>
-            <a:r>
-              <a:t>Sexually Transmitted Infections (STIs)</a:t>
-            </a:r>
-          </a:p>
-        </p:txBody>
-      </p:sp>
-      <p:sp>
-        <p:nvSpPr>
-          <p:cNvPr id="3" name="Content Placeholder 2"/>
-          <p:cNvSpPr>
-            <a:spLocks noGrp="1"/>
-          </p:cNvSpPr>
-          <p:nvPr>
-            <p:ph idx="1"/>
-          </p:nvPr>
-        </p:nvSpPr>
-        <p:spPr/>
-        <p:txBody>
-          <a:bodyPr/>
-          <a:lstStyle/>
-          <a:p>
-            <a:pPr/>
-            <a:r>
-              <a:t>Types of STIs</a:t>
-            </a:r>
-          </a:p>
-          <a:p>
-            <a:pPr/>
-            <a:r>
-              <a:t>Causes and Symptoms</a:t>
-            </a:r>
-          </a:p>
-          <a:p>
-            <a:pPr/>
-            <a:r>
-              <a:t>Prevention Methods</a:t>
-            </a:r>
-          </a:p>
-          <a:p>
-            <a:pPr/>
-            <a:r>
-              <a:t>Treatment Options</a:t>
+      <p:pic>
+        <p:nvPicPr>
+          <p:cNvPr id="2" name="Picture 1" descr="background.jpg"/>
+          <p:cNvPicPr>
+            <a:picLocks noChangeAspect="1"/>
+          </p:cNvPicPr>
+          <p:nvPr/>
+        </p:nvPicPr>
+        <p:blipFill>
+          <a:blip r:embed="rId2"/>
+          <a:stretch>
+            <a:fillRect/>
+          </a:stretch>
+        </p:blipFill>
+        <p:spPr>
+          <a:xfrm>
+            <a:off x="0" y="0"/>
+            <a:ext cx="9144000" cy="6858000"/>
+          </a:xfrm>
+          <a:prstGeom prst="rect">
+            <a:avLst/>
+          </a:prstGeom>
+        </p:spPr>
+      </p:pic>
+      <p:pic>
+        <p:nvPicPr>
+          <p:cNvPr id="3" name="Picture 2" descr="logo.png"/>
+          <p:cNvPicPr>
+            <a:picLocks noChangeAspect="1"/>
+          </p:cNvPicPr>
+          <p:nvPr/>
+        </p:nvPicPr>
+        <p:blipFill>
+          <a:blip r:embed="rId3"/>
+          <a:stretch>
+            <a:fillRect/>
+          </a:stretch>
+        </p:blipFill>
+        <p:spPr>
+          <a:xfrm>
+            <a:off x="7315200" y="320040"/>
+            <a:ext cx="731520" cy="731520"/>
+          </a:xfrm>
+          <a:prstGeom prst="rect">
+            <a:avLst/>
+          </a:prstGeom>
+        </p:spPr>
+      </p:pic>
+      <p:sp>
+        <p:nvSpPr>
+          <p:cNvPr id="4" name="TextBox 3"/>
+          <p:cNvSpPr txBox="1"/>
+          <p:nvPr/>
+        </p:nvSpPr>
+        <p:spPr>
+          <a:xfrm>
+            <a:off x="1645920" y="1097280"/>
+            <a:ext cx="7498079" cy="914400"/>
+          </a:xfrm>
+          <a:prstGeom prst="rect">
+            <a:avLst/>
+          </a:prstGeom>
+          <a:noFill/>
+        </p:spPr>
+        <p:txBody>
+          <a:bodyPr wrap="none">
+            <a:spAutoFit/>
+          </a:bodyPr>
+          <a:lstStyle/>
+          <a:p>
+            <a:pPr algn="l">
+              <a:defRPr sz="3200" b="1">
+                <a:solidFill>
+                  <a:srgbClr val="222222"/>
+                </a:solidFill>
+                <a:latin typeface="Aptos"/>
+              </a:defRPr>
+            </a:pPr>
+            <a:r>
+              <a:t>Main Concepts</a:t>
+            </a:r>
+          </a:p>
+        </p:txBody>
+      </p:sp>
+      <p:sp>
+        <p:nvSpPr>
+          <p:cNvPr id="5" name="TextBox 4"/>
+          <p:cNvSpPr txBox="1"/>
+          <p:nvPr/>
+        </p:nvSpPr>
+        <p:spPr>
+          <a:xfrm>
+            <a:off x="731520" y="1600200"/>
+            <a:ext cx="4754880" cy="4206240"/>
+          </a:xfrm>
+          <a:prstGeom prst="rect">
+            <a:avLst/>
+          </a:prstGeom>
+          <a:noFill/>
+        </p:spPr>
+        <p:txBody>
+          <a:bodyPr wrap="square">
+            <a:spAutoFit/>
+          </a:bodyPr>
+          <a:lstStyle/>
+          <a:p>
+            <a:pPr>
+              <a:spcAft>
+                <a:spcPts val="800"/>
+              </a:spcAft>
+              <a:defRPr sz="1800">
+                <a:solidFill>
+                  <a:srgbClr val="323232"/>
+                </a:solidFill>
+                <a:latin typeface="Aptos"/>
+              </a:defRPr>
+            </a:pPr>
+            <a:r>
+              <a:t>• Purpose and meaning of life</a:t>
+            </a:r>
+          </a:p>
+          <a:p>
+            <a:pPr>
+              <a:spcAft>
+                <a:spcPts val="800"/>
+              </a:spcAft>
+              <a:defRPr sz="1800">
+                <a:solidFill>
+                  <a:srgbClr val="323232"/>
+                </a:solidFill>
+                <a:latin typeface="Aptos"/>
+              </a:defRPr>
+            </a:pPr>
+            <a:r>
+              <a:t>• Happiness and fulfillment strategies</a:t>
+            </a:r>
+          </a:p>
+          <a:p>
+            <a:pPr>
+              <a:spcAft>
+                <a:spcPts val="800"/>
+              </a:spcAft>
+              <a:defRPr sz="1800">
+                <a:solidFill>
+                  <a:srgbClr val="323232"/>
+                </a:solidFill>
+                <a:latin typeface="Aptos"/>
+              </a:defRPr>
+            </a:pPr>
+            <a:r>
+              <a:t>• Personal growth and self-improvement</a:t>
+            </a:r>
+          </a:p>
+          <a:p>
+            <a:pPr>
+              <a:spcAft>
+                <a:spcPts val="800"/>
+              </a:spcAft>
+              <a:defRPr sz="1800">
+                <a:solidFill>
+                  <a:srgbClr val="323232"/>
+                </a:solidFill>
+                <a:latin typeface="Aptos"/>
+              </a:defRPr>
+            </a:pPr>
+            <a:r>
+              <a:t>• Overcoming obstacles and challenges</a:t>
+            </a:r>
+          </a:p>
+          <a:p>
+            <a:pPr>
+              <a:spcAft>
+                <a:spcPts val="800"/>
+              </a:spcAft>
+              <a:defRPr sz="1800">
+                <a:solidFill>
+                  <a:srgbClr val="323232"/>
+                </a:solidFill>
+                <a:latin typeface="Aptos"/>
+              </a:defRPr>
+            </a:pPr>
+            <a:r>
+              <a:t>• Building strong relationships and connections</a:t>
             </a:r>
           </a:p>
         </p:txBody>
@@ -3390,63 +4261,189 @@
         <p:nvPr/>
       </p:nvGrpSpPr>
       <p:grpSpPr/>
-      <p:sp>
-        <p:nvSpPr>
-          <p:cNvPr id="2" name="Title 1"/>
-          <p:cNvSpPr>
-            <a:spLocks noGrp="1"/>
-          </p:cNvSpPr>
-          <p:nvPr>
-            <p:ph type="title"/>
-          </p:nvPr>
-        </p:nvSpPr>
-        <p:spPr/>
-        <p:txBody>
-          <a:bodyPr/>
-          <a:lstStyle/>
-          <a:p>
-            <a:r>
-              <a:t>Consent and Communication</a:t>
-            </a:r>
-          </a:p>
-        </p:txBody>
-      </p:sp>
-      <p:sp>
-        <p:nvSpPr>
-          <p:cNvPr id="3" name="Content Placeholder 2"/>
-          <p:cNvSpPr>
-            <a:spLocks noGrp="1"/>
-          </p:cNvSpPr>
-          <p:nvPr>
-            <p:ph idx="1"/>
-          </p:nvPr>
-        </p:nvSpPr>
-        <p:spPr/>
-        <p:txBody>
-          <a:bodyPr/>
-          <a:lstStyle/>
-          <a:p>
-            <a:pPr/>
-            <a:r>
-              <a:t>Understanding Consent</a:t>
-            </a:r>
-          </a:p>
-          <a:p>
-            <a:pPr/>
-            <a:r>
-              <a:t>Effective Communication</a:t>
-            </a:r>
-          </a:p>
-          <a:p>
-            <a:pPr/>
-            <a:r>
-              <a:t>Respecting Boundaries</a:t>
-            </a:r>
-          </a:p>
-          <a:p>
-            <a:pPr/>
-            <a:r>
-              <a:t>Building Healthy Relationships</a:t>
+      <p:pic>
+        <p:nvPicPr>
+          <p:cNvPr id="2" name="Picture 1" descr="background.jpg"/>
+          <p:cNvPicPr>
+            <a:picLocks noChangeAspect="1"/>
+          </p:cNvPicPr>
+          <p:nvPr/>
+        </p:nvPicPr>
+        <p:blipFill>
+          <a:blip r:embed="rId2"/>
+          <a:stretch>
+            <a:fillRect/>
+          </a:stretch>
+        </p:blipFill>
+        <p:spPr>
+          <a:xfrm>
+            <a:off x="0" y="0"/>
+            <a:ext cx="9144000" cy="6858000"/>
+          </a:xfrm>
+          <a:prstGeom prst="rect">
+            <a:avLst/>
+          </a:prstGeom>
+        </p:spPr>
+      </p:pic>
+      <p:pic>
+        <p:nvPicPr>
+          <p:cNvPr id="3" name="Picture 2" descr="logo.png"/>
+          <p:cNvPicPr>
+            <a:picLocks noChangeAspect="1"/>
+          </p:cNvPicPr>
+          <p:nvPr/>
+        </p:nvPicPr>
+        <p:blipFill>
+          <a:blip r:embed="rId3"/>
+          <a:stretch>
+            <a:fillRect/>
+          </a:stretch>
+        </p:blipFill>
+        <p:spPr>
+          <a:xfrm>
+            <a:off x="7315200" y="320040"/>
+            <a:ext cx="731520" cy="731520"/>
+          </a:xfrm>
+          <a:prstGeom prst="rect">
+            <a:avLst/>
+          </a:prstGeom>
+        </p:spPr>
+      </p:pic>
+      <p:sp>
+        <p:nvSpPr>
+          <p:cNvPr id="4" name="TextBox 3"/>
+          <p:cNvSpPr txBox="1"/>
+          <p:nvPr/>
+        </p:nvSpPr>
+        <p:spPr>
+          <a:xfrm>
+            <a:off x="1645920" y="1097280"/>
+            <a:ext cx="7498079" cy="914400"/>
+          </a:xfrm>
+          <a:prstGeom prst="rect">
+            <a:avLst/>
+          </a:prstGeom>
+          <a:noFill/>
+        </p:spPr>
+        <p:txBody>
+          <a:bodyPr wrap="none">
+            <a:spAutoFit/>
+          </a:bodyPr>
+          <a:lstStyle/>
+          <a:p>
+            <a:pPr algn="l">
+              <a:defRPr sz="3200" b="1">
+                <a:solidFill>
+                  <a:srgbClr val="222222"/>
+                </a:solidFill>
+                <a:latin typeface="Aptos"/>
+              </a:defRPr>
+            </a:pPr>
+            <a:r>
+              <a:t>Key Features</a:t>
+            </a:r>
+          </a:p>
+        </p:txBody>
+      </p:sp>
+      <p:sp>
+        <p:nvSpPr>
+          <p:cNvPr id="5" name="TextBox 4"/>
+          <p:cNvSpPr txBox="1"/>
+          <p:nvPr/>
+        </p:nvSpPr>
+        <p:spPr>
+          <a:xfrm>
+            <a:off x="731520" y="1600200"/>
+            <a:ext cx="4754880" cy="4206240"/>
+          </a:xfrm>
+          <a:prstGeom prst="rect">
+            <a:avLst/>
+          </a:prstGeom>
+          <a:noFill/>
+        </p:spPr>
+        <p:txBody>
+          <a:bodyPr wrap="square">
+            <a:spAutoFit/>
+          </a:bodyPr>
+          <a:lstStyle/>
+          <a:p>
+            <a:pPr>
+              <a:spcAft>
+                <a:spcPts val="800"/>
+              </a:spcAft>
+              <a:defRPr sz="1800">
+                <a:solidFill>
+                  <a:srgbClr val="323232"/>
+                </a:solidFill>
+                <a:latin typeface="Aptos"/>
+              </a:defRPr>
+            </a:pPr>
+            <a:r>
+              <a:t>• Uniqueness and individuality of each person</a:t>
+            </a:r>
+          </a:p>
+          <a:p>
+            <a:pPr>
+              <a:spcAft>
+                <a:spcPts val="800"/>
+              </a:spcAft>
+              <a:defRPr sz="1800">
+                <a:solidFill>
+                  <a:srgbClr val="323232"/>
+                </a:solidFill>
+                <a:latin typeface="Aptos"/>
+              </a:defRPr>
+            </a:pPr>
+            <a:r>
+              <a:t>• Diversity and complexity of human experiences</a:t>
+            </a:r>
+          </a:p>
+          <a:p>
+            <a:pPr>
+              <a:spcAft>
+                <a:spcPts val="800"/>
+              </a:spcAft>
+              <a:defRPr sz="1800">
+                <a:solidFill>
+                  <a:srgbClr val="323232"/>
+                </a:solidFill>
+                <a:latin typeface="Aptos"/>
+              </a:defRPr>
+            </a:pPr>
+            <a:r>
+              <a:t>• Importance of self-awareness and reflection</a:t>
+            </a:r>
+          </a:p>
+          <a:p>
+            <a:pPr>
+              <a:spcAft>
+                <a:spcPts val="800"/>
+              </a:spcAft>
+              <a:defRPr sz="1800">
+                <a:solidFill>
+                  <a:srgbClr val="323232"/>
+                </a:solidFill>
+                <a:latin typeface="Aptos"/>
+              </a:defRPr>
+            </a:pPr>
+            <a:r>
+              <a:t>• Role of goals, values, and motivation</a:t>
+            </a:r>
+          </a:p>
+          <a:p>
+            <a:pPr>
+              <a:spcAft>
+                <a:spcPts val="800"/>
+              </a:spcAft>
+              <a:defRPr sz="1800">
+                <a:solidFill>
+                  <a:srgbClr val="323232"/>
+                </a:solidFill>
+                <a:latin typeface="Aptos"/>
+              </a:defRPr>
+            </a:pPr>
+            <a:r>
+              <a:t>• Impact of lifestyle and well-being</a:t>
             </a:r>
           </a:p>
         </p:txBody>
@@ -3469,63 +4466,804 @@
         <p:nvPr/>
       </p:nvGrpSpPr>
       <p:grpSpPr/>
-      <p:sp>
-        <p:nvSpPr>
-          <p:cNvPr id="2" name="Title 1"/>
-          <p:cNvSpPr>
-            <a:spLocks noGrp="1"/>
-          </p:cNvSpPr>
-          <p:nvPr>
-            <p:ph type="title"/>
-          </p:nvPr>
-        </p:nvSpPr>
-        <p:spPr/>
-        <p:txBody>
-          <a:bodyPr/>
-          <a:lstStyle/>
-          <a:p>
-            <a:r>
-              <a:t>Sexual Health and Wellness</a:t>
-            </a:r>
-          </a:p>
-        </p:txBody>
-      </p:sp>
-      <p:sp>
-        <p:nvSpPr>
-          <p:cNvPr id="3" name="Content Placeholder 2"/>
-          <p:cNvSpPr>
-            <a:spLocks noGrp="1"/>
-          </p:cNvSpPr>
-          <p:nvPr>
-            <p:ph idx="1"/>
-          </p:nvPr>
-        </p:nvSpPr>
-        <p:spPr/>
-        <p:txBody>
-          <a:bodyPr/>
-          <a:lstStyle/>
-          <a:p>
-            <a:pPr/>
-            <a:r>
-              <a:t>Practicing Safe Sex</a:t>
-            </a:r>
-          </a:p>
-          <a:p>
-            <a:pPr/>
-            <a:r>
-              <a:t>Maintaining Good Hygiene</a:t>
-            </a:r>
-          </a:p>
-          <a:p>
-            <a:pPr/>
-            <a:r>
-              <a:t>Emotional and Mental Wellbeing</a:t>
-            </a:r>
-          </a:p>
-          <a:p>
-            <a:pPr/>
-            <a:r>
-              <a:t>Seeking Help and Resources</a:t>
+      <p:pic>
+        <p:nvPicPr>
+          <p:cNvPr id="2" name="Picture 1" descr="background.jpg"/>
+          <p:cNvPicPr>
+            <a:picLocks noChangeAspect="1"/>
+          </p:cNvPicPr>
+          <p:nvPr/>
+        </p:nvPicPr>
+        <p:blipFill>
+          <a:blip r:embed="rId2"/>
+          <a:stretch>
+            <a:fillRect/>
+          </a:stretch>
+        </p:blipFill>
+        <p:spPr>
+          <a:xfrm>
+            <a:off x="0" y="0"/>
+            <a:ext cx="9144000" cy="6858000"/>
+          </a:xfrm>
+          <a:prstGeom prst="rect">
+            <a:avLst/>
+          </a:prstGeom>
+        </p:spPr>
+      </p:pic>
+      <p:pic>
+        <p:nvPicPr>
+          <p:cNvPr id="3" name="Picture 2" descr="logo.png"/>
+          <p:cNvPicPr>
+            <a:picLocks noChangeAspect="1"/>
+          </p:cNvPicPr>
+          <p:nvPr/>
+        </p:nvPicPr>
+        <p:blipFill>
+          <a:blip r:embed="rId3"/>
+          <a:stretch>
+            <a:fillRect/>
+          </a:stretch>
+        </p:blipFill>
+        <p:spPr>
+          <a:xfrm>
+            <a:off x="7315200" y="320040"/>
+            <a:ext cx="731520" cy="731520"/>
+          </a:xfrm>
+          <a:prstGeom prst="rect">
+            <a:avLst/>
+          </a:prstGeom>
+        </p:spPr>
+      </p:pic>
+      <p:sp>
+        <p:nvSpPr>
+          <p:cNvPr id="4" name="TextBox 3"/>
+          <p:cNvSpPr txBox="1"/>
+          <p:nvPr/>
+        </p:nvSpPr>
+        <p:spPr>
+          <a:xfrm>
+            <a:off x="1645920" y="1097280"/>
+            <a:ext cx="7498079" cy="914400"/>
+          </a:xfrm>
+          <a:prstGeom prst="rect">
+            <a:avLst/>
+          </a:prstGeom>
+          <a:noFill/>
+        </p:spPr>
+        <p:txBody>
+          <a:bodyPr wrap="none">
+            <a:spAutoFit/>
+          </a:bodyPr>
+          <a:lstStyle/>
+          <a:p>
+            <a:pPr algn="l">
+              <a:defRPr sz="3200" b="1">
+                <a:solidFill>
+                  <a:srgbClr val="222222"/>
+                </a:solidFill>
+                <a:latin typeface="Aptos"/>
+              </a:defRPr>
+            </a:pPr>
+            <a:r>
+              <a:t>Benefits</a:t>
+            </a:r>
+          </a:p>
+        </p:txBody>
+      </p:sp>
+      <p:sp>
+        <p:nvSpPr>
+          <p:cNvPr id="5" name="TextBox 4"/>
+          <p:cNvSpPr txBox="1"/>
+          <p:nvPr/>
+        </p:nvSpPr>
+        <p:spPr>
+          <a:xfrm>
+            <a:off x="731520" y="1600200"/>
+            <a:ext cx="4754880" cy="4206240"/>
+          </a:xfrm>
+          <a:prstGeom prst="rect">
+            <a:avLst/>
+          </a:prstGeom>
+          <a:noFill/>
+        </p:spPr>
+        <p:txBody>
+          <a:bodyPr wrap="square">
+            <a:spAutoFit/>
+          </a:bodyPr>
+          <a:lstStyle/>
+          <a:p>
+            <a:pPr>
+              <a:spcAft>
+                <a:spcPts val="800"/>
+              </a:spcAft>
+              <a:defRPr sz="1800">
+                <a:solidFill>
+                  <a:srgbClr val="323232"/>
+                </a:solidFill>
+                <a:latin typeface="Aptos"/>
+              </a:defRPr>
+            </a:pPr>
+            <a:r>
+              <a:t>• Increased self-awareness and confidence</a:t>
+            </a:r>
+          </a:p>
+          <a:p>
+            <a:pPr>
+              <a:spcAft>
+                <a:spcPts val="800"/>
+              </a:spcAft>
+              <a:defRPr sz="1800">
+                <a:solidFill>
+                  <a:srgbClr val="323232"/>
+                </a:solidFill>
+                <a:latin typeface="Aptos"/>
+              </a:defRPr>
+            </a:pPr>
+            <a:r>
+              <a:t>• Improved mental and physical health</a:t>
+            </a:r>
+          </a:p>
+          <a:p>
+            <a:pPr>
+              <a:spcAft>
+                <a:spcPts val="800"/>
+              </a:spcAft>
+              <a:defRPr sz="1800">
+                <a:solidFill>
+                  <a:srgbClr val="323232"/>
+                </a:solidFill>
+                <a:latin typeface="Aptos"/>
+              </a:defRPr>
+            </a:pPr>
+            <a:r>
+              <a:t>• Stronger, more meaningful relationships</a:t>
+            </a:r>
+          </a:p>
+          <a:p>
+            <a:pPr>
+              <a:spcAft>
+                <a:spcPts val="800"/>
+              </a:spcAft>
+              <a:defRPr sz="1800">
+                <a:solidFill>
+                  <a:srgbClr val="323232"/>
+                </a:solidFill>
+                <a:latin typeface="Aptos"/>
+              </a:defRPr>
+            </a:pPr>
+            <a:r>
+              <a:t>• Greater sense of purpose and direction</a:t>
+            </a:r>
+          </a:p>
+          <a:p>
+            <a:pPr>
+              <a:spcAft>
+                <a:spcPts val="800"/>
+              </a:spcAft>
+              <a:defRPr sz="1800">
+                <a:solidFill>
+                  <a:srgbClr val="323232"/>
+                </a:solidFill>
+                <a:latin typeface="Aptos"/>
+              </a:defRPr>
+            </a:pPr>
+            <a:r>
+              <a:t>• Enhanced overall well-being and happiness</a:t>
+            </a:r>
+          </a:p>
+        </p:txBody>
+      </p:sp>
+    </p:spTree>
+  </p:cSld>
+  <p:clrMapOvr>
+    <a:masterClrMapping/>
+  </p:clrMapOvr>
+</p:sld>
+</file>
+
+<file path=ppt/slides/slide7.xml><?xml version="1.0" encoding="utf-8"?>
+<p:sld xmlns:a="http://schemas.openxmlformats.org/drawingml/2006/main" xmlns:p="http://schemas.openxmlformats.org/presentationml/2006/main" xmlns:r="http://schemas.openxmlformats.org/officeDocument/2006/relationships">
+  <p:cSld>
+    <p:spTree>
+      <p:nvGrpSpPr>
+        <p:cNvPr id="1" name=""/>
+        <p:cNvGrpSpPr/>
+        <p:nvPr/>
+      </p:nvGrpSpPr>
+      <p:grpSpPr/>
+      <p:pic>
+        <p:nvPicPr>
+          <p:cNvPr id="2" name="Picture 1" descr="background.jpg"/>
+          <p:cNvPicPr>
+            <a:picLocks noChangeAspect="1"/>
+          </p:cNvPicPr>
+          <p:nvPr/>
+        </p:nvPicPr>
+        <p:blipFill>
+          <a:blip r:embed="rId2"/>
+          <a:stretch>
+            <a:fillRect/>
+          </a:stretch>
+        </p:blipFill>
+        <p:spPr>
+          <a:xfrm>
+            <a:off x="0" y="0"/>
+            <a:ext cx="9144000" cy="6858000"/>
+          </a:xfrm>
+          <a:prstGeom prst="rect">
+            <a:avLst/>
+          </a:prstGeom>
+        </p:spPr>
+      </p:pic>
+      <p:pic>
+        <p:nvPicPr>
+          <p:cNvPr id="3" name="Picture 2" descr="logo.png"/>
+          <p:cNvPicPr>
+            <a:picLocks noChangeAspect="1"/>
+          </p:cNvPicPr>
+          <p:nvPr/>
+        </p:nvPicPr>
+        <p:blipFill>
+          <a:blip r:embed="rId3"/>
+          <a:stretch>
+            <a:fillRect/>
+          </a:stretch>
+        </p:blipFill>
+        <p:spPr>
+          <a:xfrm>
+            <a:off x="7315200" y="320040"/>
+            <a:ext cx="731520" cy="731520"/>
+          </a:xfrm>
+          <a:prstGeom prst="rect">
+            <a:avLst/>
+          </a:prstGeom>
+        </p:spPr>
+      </p:pic>
+      <p:sp>
+        <p:nvSpPr>
+          <p:cNvPr id="4" name="TextBox 3"/>
+          <p:cNvSpPr txBox="1"/>
+          <p:nvPr/>
+        </p:nvSpPr>
+        <p:spPr>
+          <a:xfrm>
+            <a:off x="1645920" y="1097280"/>
+            <a:ext cx="7498079" cy="914400"/>
+          </a:xfrm>
+          <a:prstGeom prst="rect">
+            <a:avLst/>
+          </a:prstGeom>
+          <a:noFill/>
+        </p:spPr>
+        <p:txBody>
+          <a:bodyPr wrap="none">
+            <a:spAutoFit/>
+          </a:bodyPr>
+          <a:lstStyle/>
+          <a:p>
+            <a:pPr algn="l">
+              <a:defRPr sz="3200" b="1">
+                <a:solidFill>
+                  <a:srgbClr val="222222"/>
+                </a:solidFill>
+                <a:latin typeface="Aptos"/>
+              </a:defRPr>
+            </a:pPr>
+            <a:r>
+              <a:t>Challenges</a:t>
+            </a:r>
+          </a:p>
+        </p:txBody>
+      </p:sp>
+      <p:sp>
+        <p:nvSpPr>
+          <p:cNvPr id="5" name="TextBox 4"/>
+          <p:cNvSpPr txBox="1"/>
+          <p:nvPr/>
+        </p:nvSpPr>
+        <p:spPr>
+          <a:xfrm>
+            <a:off x="731520" y="1600200"/>
+            <a:ext cx="4754880" cy="4206240"/>
+          </a:xfrm>
+          <a:prstGeom prst="rect">
+            <a:avLst/>
+          </a:prstGeom>
+          <a:noFill/>
+        </p:spPr>
+        <p:txBody>
+          <a:bodyPr wrap="square">
+            <a:spAutoFit/>
+          </a:bodyPr>
+          <a:lstStyle/>
+          <a:p>
+            <a:pPr>
+              <a:spcAft>
+                <a:spcPts val="800"/>
+              </a:spcAft>
+              <a:defRPr sz="1800">
+                <a:solidFill>
+                  <a:srgbClr val="323232"/>
+                </a:solidFill>
+                <a:latin typeface="Aptos"/>
+              </a:defRPr>
+            </a:pPr>
+            <a:r>
+              <a:t>• Facing and overcoming fears and doubts</a:t>
+            </a:r>
+          </a:p>
+          <a:p>
+            <a:pPr>
+              <a:spcAft>
+                <a:spcPts val="800"/>
+              </a:spcAft>
+              <a:defRPr sz="1800">
+                <a:solidFill>
+                  <a:srgbClr val="323232"/>
+                </a:solidFill>
+                <a:latin typeface="Aptos"/>
+              </a:defRPr>
+            </a:pPr>
+            <a:r>
+              <a:t>• Dealing with stress, anxiety, and uncertainty</a:t>
+            </a:r>
+          </a:p>
+          <a:p>
+            <a:pPr>
+              <a:spcAft>
+                <a:spcPts val="800"/>
+              </a:spcAft>
+              <a:defRPr sz="1800">
+                <a:solidFill>
+                  <a:srgbClr val="323232"/>
+                </a:solidFill>
+                <a:latin typeface="Aptos"/>
+              </a:defRPr>
+            </a:pPr>
+            <a:r>
+              <a:t>• Building resilience and coping mechanisms</a:t>
+            </a:r>
+          </a:p>
+          <a:p>
+            <a:pPr>
+              <a:spcAft>
+                <a:spcPts val="800"/>
+              </a:spcAft>
+              <a:defRPr sz="1800">
+                <a:solidFill>
+                  <a:srgbClr val="323232"/>
+                </a:solidFill>
+                <a:latin typeface="Aptos"/>
+              </a:defRPr>
+            </a:pPr>
+            <a:r>
+              <a:t>• Managing change and adapting to new situations</a:t>
+            </a:r>
+          </a:p>
+          <a:p>
+            <a:pPr>
+              <a:spcAft>
+                <a:spcPts val="800"/>
+              </a:spcAft>
+              <a:defRPr sz="1800">
+                <a:solidFill>
+                  <a:srgbClr val="323232"/>
+                </a:solidFill>
+                <a:latin typeface="Aptos"/>
+              </a:defRPr>
+            </a:pPr>
+            <a:r>
+              <a:t>• Maintaining a healthy work-life balance</a:t>
+            </a:r>
+          </a:p>
+        </p:txBody>
+      </p:sp>
+    </p:spTree>
+  </p:cSld>
+  <p:clrMapOvr>
+    <a:masterClrMapping/>
+  </p:clrMapOvr>
+</p:sld>
+</file>
+
+<file path=ppt/slides/slide8.xml><?xml version="1.0" encoding="utf-8"?>
+<p:sld xmlns:a="http://schemas.openxmlformats.org/drawingml/2006/main" xmlns:p="http://schemas.openxmlformats.org/presentationml/2006/main" xmlns:r="http://schemas.openxmlformats.org/officeDocument/2006/relationships">
+  <p:cSld>
+    <p:spTree>
+      <p:nvGrpSpPr>
+        <p:cNvPr id="1" name=""/>
+        <p:cNvGrpSpPr/>
+        <p:nvPr/>
+      </p:nvGrpSpPr>
+      <p:grpSpPr/>
+      <p:pic>
+        <p:nvPicPr>
+          <p:cNvPr id="2" name="Picture 1" descr="background.jpg"/>
+          <p:cNvPicPr>
+            <a:picLocks noChangeAspect="1"/>
+          </p:cNvPicPr>
+          <p:nvPr/>
+        </p:nvPicPr>
+        <p:blipFill>
+          <a:blip r:embed="rId2"/>
+          <a:stretch>
+            <a:fillRect/>
+          </a:stretch>
+        </p:blipFill>
+        <p:spPr>
+          <a:xfrm>
+            <a:off x="0" y="0"/>
+            <a:ext cx="9144000" cy="6858000"/>
+          </a:xfrm>
+          <a:prstGeom prst="rect">
+            <a:avLst/>
+          </a:prstGeom>
+        </p:spPr>
+      </p:pic>
+      <p:pic>
+        <p:nvPicPr>
+          <p:cNvPr id="3" name="Picture 2" descr="logo.png"/>
+          <p:cNvPicPr>
+            <a:picLocks noChangeAspect="1"/>
+          </p:cNvPicPr>
+          <p:nvPr/>
+        </p:nvPicPr>
+        <p:blipFill>
+          <a:blip r:embed="rId3"/>
+          <a:stretch>
+            <a:fillRect/>
+          </a:stretch>
+        </p:blipFill>
+        <p:spPr>
+          <a:xfrm>
+            <a:off x="7315200" y="320040"/>
+            <a:ext cx="731520" cy="731520"/>
+          </a:xfrm>
+          <a:prstGeom prst="rect">
+            <a:avLst/>
+          </a:prstGeom>
+        </p:spPr>
+      </p:pic>
+      <p:sp>
+        <p:nvSpPr>
+          <p:cNvPr id="4" name="TextBox 3"/>
+          <p:cNvSpPr txBox="1"/>
+          <p:nvPr/>
+        </p:nvSpPr>
+        <p:spPr>
+          <a:xfrm>
+            <a:off x="1645920" y="1097280"/>
+            <a:ext cx="7498079" cy="914400"/>
+          </a:xfrm>
+          <a:prstGeom prst="rect">
+            <a:avLst/>
+          </a:prstGeom>
+          <a:noFill/>
+        </p:spPr>
+        <p:txBody>
+          <a:bodyPr wrap="none">
+            <a:spAutoFit/>
+          </a:bodyPr>
+          <a:lstStyle/>
+          <a:p>
+            <a:pPr algn="l">
+              <a:defRPr sz="3200" b="1">
+                <a:solidFill>
+                  <a:srgbClr val="222222"/>
+                </a:solidFill>
+                <a:latin typeface="Aptos"/>
+              </a:defRPr>
+            </a:pPr>
+            <a:r>
+              <a:t>Real-world Applications</a:t>
+            </a:r>
+          </a:p>
+        </p:txBody>
+      </p:sp>
+      <p:sp>
+        <p:nvSpPr>
+          <p:cNvPr id="5" name="TextBox 4"/>
+          <p:cNvSpPr txBox="1"/>
+          <p:nvPr/>
+        </p:nvSpPr>
+        <p:spPr>
+          <a:xfrm>
+            <a:off x="731520" y="1600200"/>
+            <a:ext cx="4754880" cy="4206240"/>
+          </a:xfrm>
+          <a:prstGeom prst="rect">
+            <a:avLst/>
+          </a:prstGeom>
+          <a:noFill/>
+        </p:spPr>
+        <p:txBody>
+          <a:bodyPr wrap="square">
+            <a:spAutoFit/>
+          </a:bodyPr>
+          <a:lstStyle/>
+          <a:p>
+            <a:pPr>
+              <a:spcAft>
+                <a:spcPts val="800"/>
+              </a:spcAft>
+              <a:defRPr sz="1800">
+                <a:solidFill>
+                  <a:srgbClr val="323232"/>
+                </a:solidFill>
+                <a:latin typeface="Aptos"/>
+              </a:defRPr>
+            </a:pPr>
+            <a:r>
+              <a:t>• Applying life skills in personal and professional settings</a:t>
+            </a:r>
+          </a:p>
+          <a:p>
+            <a:pPr>
+              <a:spcAft>
+                <a:spcPts val="800"/>
+              </a:spcAft>
+              <a:defRPr sz="1800">
+                <a:solidFill>
+                  <a:srgbClr val="323232"/>
+                </a:solidFill>
+                <a:latin typeface="Aptos"/>
+              </a:defRPr>
+            </a:pPr>
+            <a:r>
+              <a:t>• Using experiences to inform decision-making</a:t>
+            </a:r>
+          </a:p>
+          <a:p>
+            <a:pPr>
+              <a:spcAft>
+                <a:spcPts val="800"/>
+              </a:spcAft>
+              <a:defRPr sz="1800">
+                <a:solidFill>
+                  <a:srgbClr val="323232"/>
+                </a:solidFill>
+                <a:latin typeface="Aptos"/>
+              </a:defRPr>
+            </a:pPr>
+            <a:r>
+              <a:t>• Developing emotional intelligence and empathy</a:t>
+            </a:r>
+          </a:p>
+          <a:p>
+            <a:pPr>
+              <a:spcAft>
+                <a:spcPts val="800"/>
+              </a:spcAft>
+              <a:defRPr sz="1800">
+                <a:solidFill>
+                  <a:srgbClr val="323232"/>
+                </a:solidFill>
+                <a:latin typeface="Aptos"/>
+              </a:defRPr>
+            </a:pPr>
+            <a:r>
+              <a:t>• Fostering a growth mindset and lifelong learning</a:t>
+            </a:r>
+          </a:p>
+          <a:p>
+            <a:pPr>
+              <a:spcAft>
+                <a:spcPts val="800"/>
+              </a:spcAft>
+              <a:defRPr sz="1800">
+                <a:solidFill>
+                  <a:srgbClr val="323232"/>
+                </a:solidFill>
+                <a:latin typeface="Aptos"/>
+              </a:defRPr>
+            </a:pPr>
+            <a:r>
+              <a:t>• Creating positive social impact and contribution</a:t>
+            </a:r>
+          </a:p>
+        </p:txBody>
+      </p:sp>
+    </p:spTree>
+  </p:cSld>
+  <p:clrMapOvr>
+    <a:masterClrMapping/>
+  </p:clrMapOvr>
+</p:sld>
+</file>
+
+<file path=ppt/slides/slide9.xml><?xml version="1.0" encoding="utf-8"?>
+<p:sld xmlns:a="http://schemas.openxmlformats.org/drawingml/2006/main" xmlns:p="http://schemas.openxmlformats.org/presentationml/2006/main" xmlns:r="http://schemas.openxmlformats.org/officeDocument/2006/relationships">
+  <p:cSld>
+    <p:spTree>
+      <p:nvGrpSpPr>
+        <p:cNvPr id="1" name=""/>
+        <p:cNvGrpSpPr/>
+        <p:nvPr/>
+      </p:nvGrpSpPr>
+      <p:grpSpPr/>
+      <p:pic>
+        <p:nvPicPr>
+          <p:cNvPr id="2" name="Picture 1" descr="background.jpg"/>
+          <p:cNvPicPr>
+            <a:picLocks noChangeAspect="1"/>
+          </p:cNvPicPr>
+          <p:nvPr/>
+        </p:nvPicPr>
+        <p:blipFill>
+          <a:blip r:embed="rId2"/>
+          <a:stretch>
+            <a:fillRect/>
+          </a:stretch>
+        </p:blipFill>
+        <p:spPr>
+          <a:xfrm>
+            <a:off x="0" y="0"/>
+            <a:ext cx="9144000" cy="6858000"/>
+          </a:xfrm>
+          <a:prstGeom prst="rect">
+            <a:avLst/>
+          </a:prstGeom>
+        </p:spPr>
+      </p:pic>
+      <p:pic>
+        <p:nvPicPr>
+          <p:cNvPr id="3" name="Picture 2" descr="logo.png"/>
+          <p:cNvPicPr>
+            <a:picLocks noChangeAspect="1"/>
+          </p:cNvPicPr>
+          <p:nvPr/>
+        </p:nvPicPr>
+        <p:blipFill>
+          <a:blip r:embed="rId3"/>
+          <a:stretch>
+            <a:fillRect/>
+          </a:stretch>
+        </p:blipFill>
+        <p:spPr>
+          <a:xfrm>
+            <a:off x="7315200" y="320040"/>
+            <a:ext cx="731520" cy="731520"/>
+          </a:xfrm>
+          <a:prstGeom prst="rect">
+            <a:avLst/>
+          </a:prstGeom>
+        </p:spPr>
+      </p:pic>
+      <p:sp>
+        <p:nvSpPr>
+          <p:cNvPr id="4" name="TextBox 3"/>
+          <p:cNvSpPr txBox="1"/>
+          <p:nvPr/>
+        </p:nvSpPr>
+        <p:spPr>
+          <a:xfrm>
+            <a:off x="1645920" y="1097280"/>
+            <a:ext cx="7498079" cy="914400"/>
+          </a:xfrm>
+          <a:prstGeom prst="rect">
+            <a:avLst/>
+          </a:prstGeom>
+          <a:noFill/>
+        </p:spPr>
+        <p:txBody>
+          <a:bodyPr wrap="none">
+            <a:spAutoFit/>
+          </a:bodyPr>
+          <a:lstStyle/>
+          <a:p>
+            <a:pPr algn="l">
+              <a:defRPr sz="3200" b="1">
+                <a:solidFill>
+                  <a:srgbClr val="222222"/>
+                </a:solidFill>
+                <a:latin typeface="Aptos"/>
+              </a:defRPr>
+            </a:pPr>
+            <a:r>
+              <a:t>Future Trends</a:t>
+            </a:r>
+          </a:p>
+        </p:txBody>
+      </p:sp>
+      <p:sp>
+        <p:nvSpPr>
+          <p:cNvPr id="5" name="TextBox 4"/>
+          <p:cNvSpPr txBox="1"/>
+          <p:nvPr/>
+        </p:nvSpPr>
+        <p:spPr>
+          <a:xfrm>
+            <a:off x="731520" y="1600200"/>
+            <a:ext cx="4754880" cy="4206240"/>
+          </a:xfrm>
+          <a:prstGeom prst="rect">
+            <a:avLst/>
+          </a:prstGeom>
+          <a:noFill/>
+        </p:spPr>
+        <p:txBody>
+          <a:bodyPr wrap="square">
+            <a:spAutoFit/>
+          </a:bodyPr>
+          <a:lstStyle/>
+          <a:p>
+            <a:pPr>
+              <a:spcAft>
+                <a:spcPts val="800"/>
+              </a:spcAft>
+              <a:defRPr sz="1800">
+                <a:solidFill>
+                  <a:srgbClr val="323232"/>
+                </a:solidFill>
+                <a:latin typeface="Aptos"/>
+              </a:defRPr>
+            </a:pPr>
+            <a:r>
+              <a:t>• Increased focus on mental health and wellness</a:t>
+            </a:r>
+          </a:p>
+          <a:p>
+            <a:pPr>
+              <a:spcAft>
+                <a:spcPts val="800"/>
+              </a:spcAft>
+              <a:defRPr sz="1800">
+                <a:solidFill>
+                  <a:srgbClr val="323232"/>
+                </a:solidFill>
+                <a:latin typeface="Aptos"/>
+              </a:defRPr>
+            </a:pPr>
+            <a:r>
+              <a:t>• Growing importance of technology and innovation</a:t>
+            </a:r>
+          </a:p>
+          <a:p>
+            <a:pPr>
+              <a:spcAft>
+                <a:spcPts val="800"/>
+              </a:spcAft>
+              <a:defRPr sz="1800">
+                <a:solidFill>
+                  <a:srgbClr val="323232"/>
+                </a:solidFill>
+                <a:latin typeface="Aptos"/>
+              </a:defRPr>
+            </a:pPr>
+            <a:r>
+              <a:t>• Shifting societal values and cultural norms</a:t>
+            </a:r>
+          </a:p>
+          <a:p>
+            <a:pPr>
+              <a:spcAft>
+                <a:spcPts val="800"/>
+              </a:spcAft>
+              <a:defRPr sz="1800">
+                <a:solidFill>
+                  <a:srgbClr val="323232"/>
+                </a:solidFill>
+                <a:latin typeface="Aptos"/>
+              </a:defRPr>
+            </a:pPr>
+            <a:r>
+              <a:t>• Evolution of work and career landscapes</a:t>
+            </a:r>
+          </a:p>
+          <a:p>
+            <a:pPr>
+              <a:spcAft>
+                <a:spcPts val="800"/>
+              </a:spcAft>
+              <a:defRPr sz="1800">
+                <a:solidFill>
+                  <a:srgbClr val="323232"/>
+                </a:solidFill>
+                <a:latin typeface="Aptos"/>
+              </a:defRPr>
+            </a:pPr>
+            <a:r>
+              <a:t>• Greater emphasis on sustainability and environmental awareness</a:t>
             </a:r>
           </a:p>
         </p:txBody>

</xml_diff>